<commit_message>
templates: eleven more built in (cover letter, memo, meeting agenda and project proposal; expense report, stock list, weekly planner and grade book; quarterly review, lesson and portfolio), each drawn in the gallery and in every language; the gallery's files and pictures made again by today's engines
</commit_message>
<xml_diff>
--- a/packages/templates/files/deck-pitch.pptx
+++ b/packages/templates/files/deck-pitch.pptx
@@ -1048,7 +1048,7 @@
           <a:lstStyle/>
           <a:p>
             <a:pPr algn="r"/>
-            <a:fld id="{6FB5D686-570D-E087-8E0E-419D49F080E6}" type="slidenum">
+            <a:fld id="{C94037A3-5219-C574-D7FB-717D4E001F89}" type="slidenum">
               <a:rPr lang="en-US"/>
               <a:t>2</a:t>
             </a:fld>
@@ -1270,7 +1270,7 @@
           <a:lstStyle/>
           <a:p>
             <a:pPr algn="r"/>
-            <a:fld id="{FDADB50F-A646-D896-0324-E2984E75F0E3}" type="slidenum">
+            <a:fld id="{E9FC2E9C-0541-84A0-C349-7DCDF2AE7520}" type="slidenum">
               <a:rPr lang="en-US"/>
               <a:t>3</a:t>
             </a:fld>
@@ -1423,7 +1423,7 @@
           <a:lstStyle/>
           <a:p>
             <a:pPr algn="r"/>
-            <a:fld id="{41CD33ED-B644-551F-09F9-A109341516DE}" type="slidenum">
+            <a:fld id="{14F48942-C3F8-6984-B825-ECE9B1651058}" type="slidenum">
               <a:rPr lang="en-US"/>
               <a:t>4</a:t>
             </a:fld>
@@ -1630,7 +1630,7 @@
           <a:lstStyle/>
           <a:p>
             <a:pPr algn="r"/>
-            <a:fld id="{E5AE8406-E5A7-F0C8-444C-5D7355EE72C7}" type="slidenum">
+            <a:fld id="{CABF1828-F94A-B21B-6AEB-971901DDDF58}" type="slidenum">
               <a:rPr lang="en-US"/>
               <a:t>5</a:t>
             </a:fld>
@@ -1948,7 +1948,7 @@
           <a:lstStyle/>
           <a:p>
             <a:pPr algn="r"/>
-            <a:fld id="{2D1EC2CB-251F-B271-F5E5-8178254A41DB}" type="slidenum">
+            <a:fld id="{158CF135-6CA8-63F1-7EFD-E9EF37DA2247}" type="slidenum">
               <a:rPr lang="en-US"/>
               <a:t>6</a:t>
             </a:fld>
@@ -2108,7 +2108,7 @@
           <a:lstStyle/>
           <a:p>
             <a:pPr algn="r"/>
-            <a:fld id="{F29EAA91-1DD4-EC33-CEA5-82030F6FED1D}" type="slidenum">
+            <a:fld id="{7FF57966-2A56-3A83-A400-115B3FEF0C5A}" type="slidenum">
               <a:rPr lang="en-US"/>
               <a:t>7</a:t>
             </a:fld>
@@ -2208,7 +2208,7 @@
           <a:lstStyle/>
           <a:p>
             <a:pPr algn="r"/>
-            <a:fld id="{5AD45EAA-E2C3-0F65-E14E-A23FAFBD585A}" type="slidenum">
+            <a:fld id="{04CE974D-E880-0661-CFCC-52CD0DAFA7B4}" type="slidenum">
               <a:rPr lang="en-US"/>
               <a:t>8</a:t>
             </a:fld>

</xml_diff>